<commit_message>
Frontend Setup- fix user dashboard route and add logout feature
</commit_message>
<xml_diff>
--- a/.lessons/51 Frontend Template Setup And Mastering/6 Frontend Setup- fix user dashboard route and add logout feature/1.pptx
+++ b/.lessons/51 Frontend Template Setup And Mastering/6 Frontend Setup- fix user dashboard route and add logout feature/1.pptx
@@ -6,8 +6,17 @@
   </p:sldMasterIdLst>
   <p:sldIdLst>
     <p:sldId id="413" r:id="rId2"/>
-    <p:sldId id="414" r:id="rId3"/>
-    <p:sldId id="400" r:id="rId4"/>
+    <p:sldId id="415" r:id="rId3"/>
+    <p:sldId id="416" r:id="rId4"/>
+    <p:sldId id="414" r:id="rId5"/>
+    <p:sldId id="400" r:id="rId6"/>
+    <p:sldId id="417" r:id="rId7"/>
+    <p:sldId id="418" r:id="rId8"/>
+    <p:sldId id="420" r:id="rId9"/>
+    <p:sldId id="422" r:id="rId10"/>
+    <p:sldId id="423" r:id="rId11"/>
+    <p:sldId id="421" r:id="rId12"/>
+    <p:sldId id="419" r:id="rId13"/>
   </p:sldIdLst>
   <p:sldSz cx="12192000" cy="6858000"/>
   <p:notesSz cx="6858000" cy="9144000"/>
@@ -261,7 +270,7 @@
           <a:p>
             <a:fld id="{3E102D2E-813C-461C-9963-687A650C48C0}" type="datetimeFigureOut">
               <a:rPr lang="en-US" smtClean="0"/>
-              <a:t>6/26/2025</a:t>
+              <a:t>8/1/2025</a:t>
             </a:fld>
             <a:endParaRPr lang="en-US"/>
           </a:p>
@@ -459,7 +468,7 @@
           <a:p>
             <a:fld id="{3E102D2E-813C-461C-9963-687A650C48C0}" type="datetimeFigureOut">
               <a:rPr lang="en-US" smtClean="0"/>
-              <a:t>6/26/2025</a:t>
+              <a:t>8/1/2025</a:t>
             </a:fld>
             <a:endParaRPr lang="en-US"/>
           </a:p>
@@ -667,7 +676,7 @@
           <a:p>
             <a:fld id="{3E102D2E-813C-461C-9963-687A650C48C0}" type="datetimeFigureOut">
               <a:rPr lang="en-US" smtClean="0"/>
-              <a:t>6/26/2025</a:t>
+              <a:t>8/1/2025</a:t>
             </a:fld>
             <a:endParaRPr lang="en-US"/>
           </a:p>
@@ -865,7 +874,7 @@
           <a:p>
             <a:fld id="{3E102D2E-813C-461C-9963-687A650C48C0}" type="datetimeFigureOut">
               <a:rPr lang="en-US" smtClean="0"/>
-              <a:t>6/26/2025</a:t>
+              <a:t>8/1/2025</a:t>
             </a:fld>
             <a:endParaRPr lang="en-US"/>
           </a:p>
@@ -1140,7 +1149,7 @@
           <a:p>
             <a:fld id="{3E102D2E-813C-461C-9963-687A650C48C0}" type="datetimeFigureOut">
               <a:rPr lang="en-US" smtClean="0"/>
-              <a:t>6/26/2025</a:t>
+              <a:t>8/1/2025</a:t>
             </a:fld>
             <a:endParaRPr lang="en-US"/>
           </a:p>
@@ -1405,7 +1414,7 @@
           <a:p>
             <a:fld id="{3E102D2E-813C-461C-9963-687A650C48C0}" type="datetimeFigureOut">
               <a:rPr lang="en-US" smtClean="0"/>
-              <a:t>6/26/2025</a:t>
+              <a:t>8/1/2025</a:t>
             </a:fld>
             <a:endParaRPr lang="en-US"/>
           </a:p>
@@ -1817,7 +1826,7 @@
           <a:p>
             <a:fld id="{3E102D2E-813C-461C-9963-687A650C48C0}" type="datetimeFigureOut">
               <a:rPr lang="en-US" smtClean="0"/>
-              <a:t>6/26/2025</a:t>
+              <a:t>8/1/2025</a:t>
             </a:fld>
             <a:endParaRPr lang="en-US"/>
           </a:p>
@@ -1958,7 +1967,7 @@
           <a:p>
             <a:fld id="{3E102D2E-813C-461C-9963-687A650C48C0}" type="datetimeFigureOut">
               <a:rPr lang="en-US" smtClean="0"/>
-              <a:t>6/26/2025</a:t>
+              <a:t>8/1/2025</a:t>
             </a:fld>
             <a:endParaRPr lang="en-US"/>
           </a:p>
@@ -2071,7 +2080,7 @@
           <a:p>
             <a:fld id="{3E102D2E-813C-461C-9963-687A650C48C0}" type="datetimeFigureOut">
               <a:rPr lang="en-US" smtClean="0"/>
-              <a:t>6/26/2025</a:t>
+              <a:t>8/1/2025</a:t>
             </a:fld>
             <a:endParaRPr lang="en-US"/>
           </a:p>
@@ -2382,7 +2391,7 @@
           <a:p>
             <a:fld id="{3E102D2E-813C-461C-9963-687A650C48C0}" type="datetimeFigureOut">
               <a:rPr lang="en-US" smtClean="0"/>
-              <a:t>6/26/2025</a:t>
+              <a:t>8/1/2025</a:t>
             </a:fld>
             <a:endParaRPr lang="en-US"/>
           </a:p>
@@ -2670,7 +2679,7 @@
           <a:p>
             <a:fld id="{3E102D2E-813C-461C-9963-687A650C48C0}" type="datetimeFigureOut">
               <a:rPr lang="en-US" smtClean="0"/>
-              <a:t>6/26/2025</a:t>
+              <a:t>8/1/2025</a:t>
             </a:fld>
             <a:endParaRPr lang="en-US"/>
           </a:p>
@@ -2911,7 +2920,7 @@
           <a:p>
             <a:fld id="{3E102D2E-813C-461C-9963-687A650C48C0}" type="datetimeFigureOut">
               <a:rPr lang="en-US" smtClean="0"/>
-              <a:t>6/26/2025</a:t>
+              <a:t>8/1/2025</a:t>
             </a:fld>
             <a:endParaRPr lang="en-US"/>
           </a:p>
@@ -3349,7 +3358,7 @@
         <p:spPr>
           <a:xfrm>
             <a:off x="217714" y="255046"/>
-            <a:ext cx="11756571" cy="355354"/>
+            <a:ext cx="11756571" cy="955518"/>
           </a:xfrm>
           <a:prstGeom prst="rect">
             <a:avLst/>
@@ -3369,7 +3378,7 @@
               <a:buNone/>
             </a:pPr>
             <a:r>
-              <a:rPr kumimoji="0" lang="en-US" altLang="en-US" sz="1300" b="0" i="0" u="none" strike="noStrike" cap="none" normalizeH="0" baseline="0">
+              <a:rPr kumimoji="0" lang="az-Latn-AZ" altLang="en-US" sz="1300" b="0" i="0" u="none" strike="noStrike" cap="none" normalizeH="0" baseline="0">
                 <a:ln>
                   <a:noFill/>
                 </a:ln>
@@ -3379,11 +3388,109 @@
                 <a:effectLst/>
                 <a:latin typeface="Arial" panose="020B0604020202020204" pitchFamily="34" charset="0"/>
               </a:rPr>
-              <a:t>.</a:t>
-            </a:r>
-          </a:p>
-        </p:txBody>
-      </p:sp>
+              <a:t>Bu dərs istifadəçi route -urunu konfiqurasiya edəcəyik.</a:t>
+            </a:r>
+          </a:p>
+          <a:p>
+            <a:pPr>
+              <a:lnSpc>
+                <a:spcPct val="150000"/>
+              </a:lnSpc>
+              <a:buNone/>
+            </a:pPr>
+            <a:endParaRPr lang="az-Latn-AZ" altLang="en-US" sz="1300">
+              <a:latin typeface="Arial" panose="020B0604020202020204" pitchFamily="34" charset="0"/>
+            </a:endParaRPr>
+          </a:p>
+          <a:p>
+            <a:pPr>
+              <a:lnSpc>
+                <a:spcPct val="150000"/>
+              </a:lnSpc>
+              <a:buNone/>
+            </a:pPr>
+            <a:r>
+              <a:rPr kumimoji="0" lang="az-Latn-AZ" altLang="en-US" sz="1300" b="0" i="0" u="none" strike="noStrike" cap="none" normalizeH="0" baseline="0">
+                <a:ln>
+                  <a:noFill/>
+                </a:ln>
+                <a:solidFill>
+                  <a:schemeClr val="tx1"/>
+                </a:solidFill>
+                <a:effectLst/>
+                <a:latin typeface="Arial" panose="020B0604020202020204" pitchFamily="34" charset="0"/>
+              </a:rPr>
+              <a:t>İlk olaraq </a:t>
+            </a:r>
+            <a:r>
+              <a:rPr kumimoji="0" lang="az-Latn-AZ" altLang="en-US" sz="1300" b="1" i="0" u="none" strike="noStrike" cap="none" normalizeH="0" baseline="0">
+                <a:ln>
+                  <a:noFill/>
+                </a:ln>
+                <a:solidFill>
+                  <a:schemeClr val="tx1"/>
+                </a:solidFill>
+                <a:effectLst/>
+                <a:latin typeface="Arial" panose="020B0604020202020204" pitchFamily="34" charset="0"/>
+              </a:rPr>
+              <a:t>UserDashboardController</a:t>
+            </a:r>
+            <a:r>
+              <a:rPr kumimoji="0" lang="az-Latn-AZ" altLang="en-US" sz="1300" b="0" i="0" u="none" strike="noStrike" cap="none" normalizeH="0" baseline="0">
+                <a:ln>
+                  <a:noFill/>
+                </a:ln>
+                <a:solidFill>
+                  <a:schemeClr val="tx1"/>
+                </a:solidFill>
+                <a:effectLst/>
+                <a:latin typeface="Arial" panose="020B0604020202020204" pitchFamily="34" charset="0"/>
+              </a:rPr>
+              <a:t> adında kontroller yaradırıq.</a:t>
+            </a:r>
+            <a:endParaRPr kumimoji="0" lang="en-US" altLang="en-US" sz="1300" b="0" i="0" u="none" strike="noStrike" cap="none" normalizeH="0" baseline="0">
+              <a:ln>
+                <a:noFill/>
+              </a:ln>
+              <a:solidFill>
+                <a:schemeClr val="tx1"/>
+              </a:solidFill>
+              <a:effectLst/>
+              <a:latin typeface="Arial" panose="020B0604020202020204" pitchFamily="34" charset="0"/>
+            </a:endParaRPr>
+          </a:p>
+        </p:txBody>
+      </p:sp>
+      <p:pic>
+        <p:nvPicPr>
+          <p:cNvPr id="4" name="Picture 3">
+            <a:extLst>
+              <a:ext uri="{FF2B5EF4-FFF2-40B4-BE49-F238E27FC236}">
+                <a16:creationId xmlns:a16="http://schemas.microsoft.com/office/drawing/2014/main" id="{6A4B028C-509C-9830-A823-C266EAA954C9}"/>
+              </a:ext>
+            </a:extLst>
+          </p:cNvPr>
+          <p:cNvPicPr>
+            <a:picLocks noChangeAspect="1"/>
+          </p:cNvPicPr>
+          <p:nvPr/>
+        </p:nvPicPr>
+        <p:blipFill>
+          <a:blip r:embed="rId2"/>
+          <a:stretch>
+            <a:fillRect/>
+          </a:stretch>
+        </p:blipFill>
+        <p:spPr>
+          <a:xfrm>
+            <a:off x="0" y="1597071"/>
+            <a:ext cx="9478698" cy="1667108"/>
+          </a:xfrm>
+          <a:prstGeom prst="rect">
+            <a:avLst/>
+          </a:prstGeom>
+        </p:spPr>
+      </p:pic>
     </p:spTree>
     <p:extLst>
       <p:ext uri="{BB962C8B-B14F-4D97-AF65-F5344CB8AC3E}">
@@ -3397,7 +3504,527 @@
 </p:sld>
 </file>
 
+<file path=ppt/slides/slide10.xml><?xml version="1.0" encoding="utf-8"?>
+<p:sld xmlns:a="http://schemas.openxmlformats.org/drawingml/2006/main" xmlns:r="http://schemas.openxmlformats.org/officeDocument/2006/relationships" xmlns:p="http://schemas.openxmlformats.org/presentationml/2006/main">
+  <p:cSld>
+    <p:spTree>
+      <p:nvGrpSpPr>
+        <p:cNvPr id="1" name="">
+          <a:extLst>
+            <a:ext uri="{FF2B5EF4-FFF2-40B4-BE49-F238E27FC236}">
+              <a16:creationId xmlns:a16="http://schemas.microsoft.com/office/drawing/2014/main" id="{5DCD0AA5-5E83-454A-A078-7250DDD588C8}"/>
+            </a:ext>
+          </a:extLst>
+        </p:cNvPr>
+        <p:cNvGrpSpPr/>
+        <p:nvPr/>
+      </p:nvGrpSpPr>
+      <p:grpSpPr>
+        <a:xfrm>
+          <a:off x="0" y="0"/>
+          <a:ext cx="0" cy="0"/>
+          <a:chOff x="0" y="0"/>
+          <a:chExt cx="0" cy="0"/>
+        </a:xfrm>
+      </p:grpSpPr>
+      <p:sp>
+        <p:nvSpPr>
+          <p:cNvPr id="3" name="TextBox 2">
+            <a:extLst>
+              <a:ext uri="{FF2B5EF4-FFF2-40B4-BE49-F238E27FC236}">
+                <a16:creationId xmlns:a16="http://schemas.microsoft.com/office/drawing/2014/main" id="{CDFE2476-6187-FCB3-7F1F-0775DCF02376}"/>
+              </a:ext>
+            </a:extLst>
+          </p:cNvPr>
+          <p:cNvSpPr txBox="1"/>
+          <p:nvPr/>
+        </p:nvSpPr>
+        <p:spPr>
+          <a:xfrm>
+            <a:off x="217714" y="255046"/>
+            <a:ext cx="11756571" cy="355354"/>
+          </a:xfrm>
+          <a:prstGeom prst="rect">
+            <a:avLst/>
+          </a:prstGeom>
+          <a:noFill/>
+        </p:spPr>
+        <p:txBody>
+          <a:bodyPr wrap="square">
+            <a:spAutoFit/>
+          </a:bodyPr>
+          <a:lstStyle/>
+          <a:p>
+            <a:pPr>
+              <a:lnSpc>
+                <a:spcPct val="150000"/>
+              </a:lnSpc>
+              <a:buNone/>
+            </a:pPr>
+            <a:r>
+              <a:rPr kumimoji="0" lang="en-US" altLang="en-US" sz="1300" b="0" i="0" u="none" strike="noStrike" cap="none" normalizeH="0" baseline="0">
+                <a:ln>
+                  <a:noFill/>
+                </a:ln>
+                <a:solidFill>
+                  <a:schemeClr val="tx1"/>
+                </a:solidFill>
+                <a:effectLst/>
+                <a:latin typeface="Arial" panose="020B0604020202020204" pitchFamily="34" charset="0"/>
+              </a:rPr>
+              <a:t>.</a:t>
+            </a:r>
+          </a:p>
+        </p:txBody>
+      </p:sp>
+    </p:spTree>
+    <p:extLst>
+      <p:ext uri="{BB962C8B-B14F-4D97-AF65-F5344CB8AC3E}">
+        <p14:creationId xmlns:p14="http://schemas.microsoft.com/office/powerpoint/2010/main" val="1412110659"/>
+      </p:ext>
+    </p:extLst>
+  </p:cSld>
+  <p:clrMapOvr>
+    <a:masterClrMapping/>
+  </p:clrMapOvr>
+</p:sld>
+</file>
+
+<file path=ppt/slides/slide11.xml><?xml version="1.0" encoding="utf-8"?>
+<p:sld xmlns:a="http://schemas.openxmlformats.org/drawingml/2006/main" xmlns:r="http://schemas.openxmlformats.org/officeDocument/2006/relationships" xmlns:p="http://schemas.openxmlformats.org/presentationml/2006/main">
+  <p:cSld>
+    <p:spTree>
+      <p:nvGrpSpPr>
+        <p:cNvPr id="1" name="">
+          <a:extLst>
+            <a:ext uri="{FF2B5EF4-FFF2-40B4-BE49-F238E27FC236}">
+              <a16:creationId xmlns:a16="http://schemas.microsoft.com/office/drawing/2014/main" id="{188FFF12-5C6E-4BEC-8AB0-E12C911F7678}"/>
+            </a:ext>
+          </a:extLst>
+        </p:cNvPr>
+        <p:cNvGrpSpPr/>
+        <p:nvPr/>
+      </p:nvGrpSpPr>
+      <p:grpSpPr>
+        <a:xfrm>
+          <a:off x="0" y="0"/>
+          <a:ext cx="0" cy="0"/>
+          <a:chOff x="0" y="0"/>
+          <a:chExt cx="0" cy="0"/>
+        </a:xfrm>
+      </p:grpSpPr>
+      <p:sp>
+        <p:nvSpPr>
+          <p:cNvPr id="3" name="TextBox 2">
+            <a:extLst>
+              <a:ext uri="{FF2B5EF4-FFF2-40B4-BE49-F238E27FC236}">
+                <a16:creationId xmlns:a16="http://schemas.microsoft.com/office/drawing/2014/main" id="{897AC4E9-E36E-299F-3793-1FA7618359B6}"/>
+              </a:ext>
+            </a:extLst>
+          </p:cNvPr>
+          <p:cNvSpPr txBox="1"/>
+          <p:nvPr/>
+        </p:nvSpPr>
+        <p:spPr>
+          <a:xfrm>
+            <a:off x="217714" y="255046"/>
+            <a:ext cx="11756571" cy="355354"/>
+          </a:xfrm>
+          <a:prstGeom prst="rect">
+            <a:avLst/>
+          </a:prstGeom>
+          <a:noFill/>
+        </p:spPr>
+        <p:txBody>
+          <a:bodyPr wrap="square">
+            <a:spAutoFit/>
+          </a:bodyPr>
+          <a:lstStyle/>
+          <a:p>
+            <a:pPr>
+              <a:lnSpc>
+                <a:spcPct val="150000"/>
+              </a:lnSpc>
+              <a:buNone/>
+            </a:pPr>
+            <a:r>
+              <a:rPr kumimoji="0" lang="en-US" altLang="en-US" sz="1300" b="0" i="0" u="none" strike="noStrike" cap="none" normalizeH="0" baseline="0">
+                <a:ln>
+                  <a:noFill/>
+                </a:ln>
+                <a:solidFill>
+                  <a:schemeClr val="tx1"/>
+                </a:solidFill>
+                <a:effectLst/>
+                <a:latin typeface="Arial" panose="020B0604020202020204" pitchFamily="34" charset="0"/>
+              </a:rPr>
+              <a:t>.</a:t>
+            </a:r>
+          </a:p>
+        </p:txBody>
+      </p:sp>
+    </p:spTree>
+    <p:extLst>
+      <p:ext uri="{BB962C8B-B14F-4D97-AF65-F5344CB8AC3E}">
+        <p14:creationId xmlns:p14="http://schemas.microsoft.com/office/powerpoint/2010/main" val="3515131669"/>
+      </p:ext>
+    </p:extLst>
+  </p:cSld>
+  <p:clrMapOvr>
+    <a:masterClrMapping/>
+  </p:clrMapOvr>
+</p:sld>
+</file>
+
+<file path=ppt/slides/slide12.xml><?xml version="1.0" encoding="utf-8"?>
+<p:sld xmlns:a="http://schemas.openxmlformats.org/drawingml/2006/main" xmlns:r="http://schemas.openxmlformats.org/officeDocument/2006/relationships" xmlns:p="http://schemas.openxmlformats.org/presentationml/2006/main">
+  <p:cSld>
+    <p:spTree>
+      <p:nvGrpSpPr>
+        <p:cNvPr id="1" name="">
+          <a:extLst>
+            <a:ext uri="{FF2B5EF4-FFF2-40B4-BE49-F238E27FC236}">
+              <a16:creationId xmlns:a16="http://schemas.microsoft.com/office/drawing/2014/main" id="{9BF6D359-F022-C331-EE8D-2B5C9CD88E99}"/>
+            </a:ext>
+          </a:extLst>
+        </p:cNvPr>
+        <p:cNvGrpSpPr/>
+        <p:nvPr/>
+      </p:nvGrpSpPr>
+      <p:grpSpPr>
+        <a:xfrm>
+          <a:off x="0" y="0"/>
+          <a:ext cx="0" cy="0"/>
+          <a:chOff x="0" y="0"/>
+          <a:chExt cx="0" cy="0"/>
+        </a:xfrm>
+      </p:grpSpPr>
+      <p:sp>
+        <p:nvSpPr>
+          <p:cNvPr id="3" name="TextBox 2">
+            <a:extLst>
+              <a:ext uri="{FF2B5EF4-FFF2-40B4-BE49-F238E27FC236}">
+                <a16:creationId xmlns:a16="http://schemas.microsoft.com/office/drawing/2014/main" id="{121D20C4-A516-3839-FB8F-A99425A18542}"/>
+              </a:ext>
+            </a:extLst>
+          </p:cNvPr>
+          <p:cNvSpPr txBox="1"/>
+          <p:nvPr/>
+        </p:nvSpPr>
+        <p:spPr>
+          <a:xfrm>
+            <a:off x="217714" y="255046"/>
+            <a:ext cx="11756571" cy="355354"/>
+          </a:xfrm>
+          <a:prstGeom prst="rect">
+            <a:avLst/>
+          </a:prstGeom>
+          <a:noFill/>
+        </p:spPr>
+        <p:txBody>
+          <a:bodyPr wrap="square">
+            <a:spAutoFit/>
+          </a:bodyPr>
+          <a:lstStyle/>
+          <a:p>
+            <a:pPr>
+              <a:lnSpc>
+                <a:spcPct val="150000"/>
+              </a:lnSpc>
+              <a:buNone/>
+            </a:pPr>
+            <a:r>
+              <a:rPr kumimoji="0" lang="en-US" altLang="en-US" sz="1300" b="0" i="0" u="none" strike="noStrike" cap="none" normalizeH="0" baseline="0">
+                <a:ln>
+                  <a:noFill/>
+                </a:ln>
+                <a:solidFill>
+                  <a:schemeClr val="tx1"/>
+                </a:solidFill>
+                <a:effectLst/>
+                <a:latin typeface="Arial" panose="020B0604020202020204" pitchFamily="34" charset="0"/>
+              </a:rPr>
+              <a:t>.</a:t>
+            </a:r>
+          </a:p>
+        </p:txBody>
+      </p:sp>
+    </p:spTree>
+    <p:extLst>
+      <p:ext uri="{BB962C8B-B14F-4D97-AF65-F5344CB8AC3E}">
+        <p14:creationId xmlns:p14="http://schemas.microsoft.com/office/powerpoint/2010/main" val="36871126"/>
+      </p:ext>
+    </p:extLst>
+  </p:cSld>
+  <p:clrMapOvr>
+    <a:masterClrMapping/>
+  </p:clrMapOvr>
+</p:sld>
+</file>
+
 <file path=ppt/slides/slide2.xml><?xml version="1.0" encoding="utf-8"?>
+<p:sld xmlns:a="http://schemas.openxmlformats.org/drawingml/2006/main" xmlns:r="http://schemas.openxmlformats.org/officeDocument/2006/relationships" xmlns:p="http://schemas.openxmlformats.org/presentationml/2006/main">
+  <p:cSld>
+    <p:spTree>
+      <p:nvGrpSpPr>
+        <p:cNvPr id="1" name="">
+          <a:extLst>
+            <a:ext uri="{FF2B5EF4-FFF2-40B4-BE49-F238E27FC236}">
+              <a16:creationId xmlns:a16="http://schemas.microsoft.com/office/drawing/2014/main" id="{311F81E5-E856-7589-F3A8-373ACCE83FCD}"/>
+            </a:ext>
+          </a:extLst>
+        </p:cNvPr>
+        <p:cNvGrpSpPr/>
+        <p:nvPr/>
+      </p:nvGrpSpPr>
+      <p:grpSpPr>
+        <a:xfrm>
+          <a:off x="0" y="0"/>
+          <a:ext cx="0" cy="0"/>
+          <a:chOff x="0" y="0"/>
+          <a:chExt cx="0" cy="0"/>
+        </a:xfrm>
+      </p:grpSpPr>
+      <p:sp>
+        <p:nvSpPr>
+          <p:cNvPr id="3" name="TextBox 2">
+            <a:extLst>
+              <a:ext uri="{FF2B5EF4-FFF2-40B4-BE49-F238E27FC236}">
+                <a16:creationId xmlns:a16="http://schemas.microsoft.com/office/drawing/2014/main" id="{9A64760A-567C-D12E-FC5A-26314095277F}"/>
+              </a:ext>
+            </a:extLst>
+          </p:cNvPr>
+          <p:cNvSpPr txBox="1"/>
+          <p:nvPr/>
+        </p:nvSpPr>
+        <p:spPr>
+          <a:xfrm>
+            <a:off x="217714" y="255046"/>
+            <a:ext cx="11756571" cy="355354"/>
+          </a:xfrm>
+          <a:prstGeom prst="rect">
+            <a:avLst/>
+          </a:prstGeom>
+          <a:noFill/>
+        </p:spPr>
+        <p:txBody>
+          <a:bodyPr wrap="square">
+            <a:spAutoFit/>
+          </a:bodyPr>
+          <a:lstStyle/>
+          <a:p>
+            <a:pPr>
+              <a:lnSpc>
+                <a:spcPct val="150000"/>
+              </a:lnSpc>
+              <a:buNone/>
+            </a:pPr>
+            <a:r>
+              <a:rPr lang="en-US" altLang="en-US" sz="1300">
+                <a:latin typeface="Arial" panose="020B0604020202020204" pitchFamily="34" charset="0"/>
+              </a:rPr>
+              <a:t>User </a:t>
+            </a:r>
+            <a:r>
+              <a:rPr lang="az-Latn-AZ" altLang="en-US" sz="1300">
+                <a:latin typeface="Arial" panose="020B0604020202020204" pitchFamily="34" charset="0"/>
+              </a:rPr>
+              <a:t>üçün route təyin edirik.</a:t>
+            </a:r>
+            <a:endParaRPr kumimoji="0" lang="en-US" altLang="en-US" sz="1300" b="0" i="0" u="none" strike="noStrike" cap="none" normalizeH="0" baseline="0">
+              <a:ln>
+                <a:noFill/>
+              </a:ln>
+              <a:solidFill>
+                <a:schemeClr val="tx1"/>
+              </a:solidFill>
+              <a:effectLst/>
+              <a:latin typeface="Arial" panose="020B0604020202020204" pitchFamily="34" charset="0"/>
+            </a:endParaRPr>
+          </a:p>
+        </p:txBody>
+      </p:sp>
+      <p:pic>
+        <p:nvPicPr>
+          <p:cNvPr id="6" name="Picture 5">
+            <a:extLst>
+              <a:ext uri="{FF2B5EF4-FFF2-40B4-BE49-F238E27FC236}">
+                <a16:creationId xmlns:a16="http://schemas.microsoft.com/office/drawing/2014/main" id="{A41B54E7-C8BE-B81F-06BB-27545D1EFD2F}"/>
+              </a:ext>
+            </a:extLst>
+          </p:cNvPr>
+          <p:cNvPicPr>
+            <a:picLocks noChangeAspect="1"/>
+          </p:cNvPicPr>
+          <p:nvPr/>
+        </p:nvPicPr>
+        <p:blipFill>
+          <a:blip r:embed="rId2"/>
+          <a:stretch>
+            <a:fillRect/>
+          </a:stretch>
+        </p:blipFill>
+        <p:spPr>
+          <a:xfrm>
+            <a:off x="-1" y="2065594"/>
+            <a:ext cx="12192000" cy="4792406"/>
+          </a:xfrm>
+          <a:prstGeom prst="rect">
+            <a:avLst/>
+          </a:prstGeom>
+        </p:spPr>
+      </p:pic>
+    </p:spTree>
+    <p:extLst>
+      <p:ext uri="{BB962C8B-B14F-4D97-AF65-F5344CB8AC3E}">
+        <p14:creationId xmlns:p14="http://schemas.microsoft.com/office/powerpoint/2010/main" val="567592802"/>
+      </p:ext>
+    </p:extLst>
+  </p:cSld>
+  <p:clrMapOvr>
+    <a:masterClrMapping/>
+  </p:clrMapOvr>
+</p:sld>
+</file>
+
+<file path=ppt/slides/slide3.xml><?xml version="1.0" encoding="utf-8"?>
+<p:sld xmlns:a="http://schemas.openxmlformats.org/drawingml/2006/main" xmlns:r="http://schemas.openxmlformats.org/officeDocument/2006/relationships" xmlns:p="http://schemas.openxmlformats.org/presentationml/2006/main">
+  <p:cSld>
+    <p:spTree>
+      <p:nvGrpSpPr>
+        <p:cNvPr id="1" name="">
+          <a:extLst>
+            <a:ext uri="{FF2B5EF4-FFF2-40B4-BE49-F238E27FC236}">
+              <a16:creationId xmlns:a16="http://schemas.microsoft.com/office/drawing/2014/main" id="{55A8CFB7-E12B-C6A4-7B75-A8BDC15269DE}"/>
+            </a:ext>
+          </a:extLst>
+        </p:cNvPr>
+        <p:cNvGrpSpPr/>
+        <p:nvPr/>
+      </p:nvGrpSpPr>
+      <p:grpSpPr>
+        <a:xfrm>
+          <a:off x="0" y="0"/>
+          <a:ext cx="0" cy="0"/>
+          <a:chOff x="0" y="0"/>
+          <a:chExt cx="0" cy="0"/>
+        </a:xfrm>
+      </p:grpSpPr>
+      <p:sp>
+        <p:nvSpPr>
+          <p:cNvPr id="3" name="TextBox 2">
+            <a:extLst>
+              <a:ext uri="{FF2B5EF4-FFF2-40B4-BE49-F238E27FC236}">
+                <a16:creationId xmlns:a16="http://schemas.microsoft.com/office/drawing/2014/main" id="{6DD585C3-845F-2B64-CD2D-A7417B59DEDF}"/>
+              </a:ext>
+            </a:extLst>
+          </p:cNvPr>
+          <p:cNvSpPr txBox="1"/>
+          <p:nvPr/>
+        </p:nvSpPr>
+        <p:spPr>
+          <a:xfrm>
+            <a:off x="217714" y="255046"/>
+            <a:ext cx="11756571" cy="355354"/>
+          </a:xfrm>
+          <a:prstGeom prst="rect">
+            <a:avLst/>
+          </a:prstGeom>
+          <a:noFill/>
+        </p:spPr>
+        <p:txBody>
+          <a:bodyPr wrap="square">
+            <a:spAutoFit/>
+          </a:bodyPr>
+          <a:lstStyle/>
+          <a:p>
+            <a:pPr>
+              <a:lnSpc>
+                <a:spcPct val="150000"/>
+              </a:lnSpc>
+              <a:buNone/>
+            </a:pPr>
+            <a:r>
+              <a:rPr lang="az-Latn-AZ" altLang="en-US" sz="1300" b="1">
+                <a:latin typeface="Arial" panose="020B0604020202020204" pitchFamily="34" charset="0"/>
+              </a:rPr>
+              <a:t>User</a:t>
+            </a:r>
+            <a:r>
+              <a:rPr lang="az-Latn-AZ" altLang="en-US" sz="1300">
+                <a:latin typeface="Arial" panose="020B0604020202020204" pitchFamily="34" charset="0"/>
+              </a:rPr>
+              <a:t> panelindən çıxış üçün `</a:t>
+            </a:r>
+            <a:r>
+              <a:rPr lang="az-Latn-AZ" altLang="en-US" sz="1300" b="1">
+                <a:latin typeface="Arial" panose="020B0604020202020204" pitchFamily="34" charset="0"/>
+              </a:rPr>
+              <a:t>Log out</a:t>
+            </a:r>
+            <a:r>
+              <a:rPr lang="az-Latn-AZ" altLang="en-US" sz="1300">
+                <a:latin typeface="Arial" panose="020B0604020202020204" pitchFamily="34" charset="0"/>
+              </a:rPr>
+              <a:t>` düyməsini konfiqurasiya edirik.</a:t>
+            </a:r>
+            <a:endParaRPr kumimoji="0" lang="en-US" altLang="en-US" sz="1300" b="0" i="0" u="none" strike="noStrike" cap="none" normalizeH="0" baseline="0">
+              <a:ln>
+                <a:noFill/>
+              </a:ln>
+              <a:solidFill>
+                <a:schemeClr val="tx1"/>
+              </a:solidFill>
+              <a:effectLst/>
+              <a:latin typeface="Arial" panose="020B0604020202020204" pitchFamily="34" charset="0"/>
+            </a:endParaRPr>
+          </a:p>
+        </p:txBody>
+      </p:sp>
+      <p:pic>
+        <p:nvPicPr>
+          <p:cNvPr id="4" name="Picture 3">
+            <a:extLst>
+              <a:ext uri="{FF2B5EF4-FFF2-40B4-BE49-F238E27FC236}">
+                <a16:creationId xmlns:a16="http://schemas.microsoft.com/office/drawing/2014/main" id="{1116C2BE-BE21-9143-C53E-6F34D5F3187B}"/>
+              </a:ext>
+            </a:extLst>
+          </p:cNvPr>
+          <p:cNvPicPr>
+            <a:picLocks noChangeAspect="1"/>
+          </p:cNvPicPr>
+          <p:nvPr/>
+        </p:nvPicPr>
+        <p:blipFill>
+          <a:blip r:embed="rId2"/>
+          <a:stretch>
+            <a:fillRect/>
+          </a:stretch>
+        </p:blipFill>
+        <p:spPr>
+          <a:xfrm>
+            <a:off x="2408460" y="1246992"/>
+            <a:ext cx="9783540" cy="5611008"/>
+          </a:xfrm>
+          <a:prstGeom prst="rect">
+            <a:avLst/>
+          </a:prstGeom>
+        </p:spPr>
+      </p:pic>
+    </p:spTree>
+    <p:extLst>
+      <p:ext uri="{BB962C8B-B14F-4D97-AF65-F5344CB8AC3E}">
+        <p14:creationId xmlns:p14="http://schemas.microsoft.com/office/powerpoint/2010/main" val="957745403"/>
+      </p:ext>
+    </p:extLst>
+  </p:cSld>
+  <p:clrMapOvr>
+    <a:masterClrMapping/>
+  </p:clrMapOvr>
+</p:sld>
+</file>
+
+<file path=ppt/slides/slide4.xml><?xml version="1.0" encoding="utf-8"?>
 <p:sld xmlns:a="http://schemas.openxmlformats.org/drawingml/2006/main" xmlns:r="http://schemas.openxmlformats.org/officeDocument/2006/relationships" xmlns:p="http://schemas.openxmlformats.org/presentationml/2006/main">
   <p:cSld>
     <p:spTree>
@@ -3435,7 +4062,7 @@
         <p:spPr>
           <a:xfrm>
             <a:off x="217714" y="255046"/>
-            <a:ext cx="11756571" cy="355354"/>
+            <a:ext cx="11756571" cy="1330557"/>
           </a:xfrm>
           <a:prstGeom prst="rect">
             <a:avLst/>
@@ -3455,21 +4082,280 @@
               <a:buNone/>
             </a:pPr>
             <a:r>
-              <a:rPr kumimoji="0" lang="en-US" altLang="en-US" sz="1300" b="0" i="0" u="none" strike="noStrike" cap="none" normalizeH="0" baseline="0">
-                <a:ln>
-                  <a:noFill/>
-                </a:ln>
-                <a:solidFill>
-                  <a:schemeClr val="tx1"/>
-                </a:solidFill>
-                <a:effectLst/>
+              <a:rPr lang="az-Latn-AZ" altLang="en-US" sz="1100">
                 <a:latin typeface="Arial" panose="020B0604020202020204" pitchFamily="34" charset="0"/>
               </a:rPr>
-              <a:t>.</a:t>
-            </a:r>
-          </a:p>
-        </p:txBody>
-      </p:sp>
+              <a:t>Artıq `</a:t>
+            </a:r>
+            <a:r>
+              <a:rPr lang="az-Latn-AZ" altLang="en-US" sz="1100" b="1">
+                <a:latin typeface="Arial" panose="020B0604020202020204" pitchFamily="34" charset="0"/>
+              </a:rPr>
+              <a:t>http://vendor-e-commerce.test/dashboard</a:t>
+            </a:r>
+            <a:r>
+              <a:rPr lang="az-Latn-AZ" altLang="en-US" sz="1100">
+                <a:latin typeface="Arial" panose="020B0604020202020204" pitchFamily="34" charset="0"/>
+              </a:rPr>
+              <a:t>` səhifəsi yodur.  </a:t>
+            </a:r>
+            <a:endParaRPr lang="en-US" altLang="en-US" sz="1100">
+              <a:latin typeface="Arial" panose="020B0604020202020204" pitchFamily="34" charset="0"/>
+            </a:endParaRPr>
+          </a:p>
+          <a:p>
+            <a:pPr>
+              <a:lnSpc>
+                <a:spcPct val="150000"/>
+              </a:lnSpc>
+              <a:buNone/>
+            </a:pPr>
+            <a:endParaRPr lang="en-US" altLang="en-US" sz="1100">
+              <a:latin typeface="Arial" panose="020B0604020202020204" pitchFamily="34" charset="0"/>
+            </a:endParaRPr>
+          </a:p>
+          <a:p>
+            <a:pPr>
+              <a:lnSpc>
+                <a:spcPct val="150000"/>
+              </a:lnSpc>
+              <a:buNone/>
+            </a:pPr>
+            <a:r>
+              <a:rPr lang="az-Latn-AZ" altLang="en-US" sz="1100">
+                <a:latin typeface="Arial" panose="020B0604020202020204" pitchFamily="34" charset="0"/>
+              </a:rPr>
+              <a:t>`</a:t>
+            </a:r>
+            <a:r>
+              <a:rPr lang="az-Latn-AZ" altLang="en-US" sz="1100" b="1">
+                <a:latin typeface="Arial" panose="020B0604020202020204" pitchFamily="34" charset="0"/>
+              </a:rPr>
+              <a:t>http://vendor-e-commerce.test/user</a:t>
+            </a:r>
+            <a:r>
+              <a:rPr lang="en-US" altLang="en-US" sz="1100" b="1">
+                <a:latin typeface="Arial" panose="020B0604020202020204" pitchFamily="34" charset="0"/>
+              </a:rPr>
+              <a:t>/</a:t>
+            </a:r>
+            <a:r>
+              <a:rPr lang="az-Latn-AZ" altLang="en-US" sz="1100" b="1">
+                <a:latin typeface="Arial" panose="020B0604020202020204" pitchFamily="34" charset="0"/>
+              </a:rPr>
+              <a:t>dashboard</a:t>
+            </a:r>
+            <a:r>
+              <a:rPr lang="az-Latn-AZ" altLang="en-US" sz="1100">
+                <a:latin typeface="Arial" panose="020B0604020202020204" pitchFamily="34" charset="0"/>
+              </a:rPr>
+              <a:t>`</a:t>
+            </a:r>
+            <a:r>
+              <a:rPr lang="en-US" altLang="en-US" sz="1100">
+                <a:latin typeface="Arial" panose="020B0604020202020204" pitchFamily="34" charset="0"/>
+              </a:rPr>
+              <a:t> s</a:t>
+            </a:r>
+            <a:r>
+              <a:rPr lang="az-Latn-AZ" altLang="en-US" sz="1100">
+                <a:latin typeface="Arial" panose="020B0604020202020204" pitchFamily="34" charset="0"/>
+              </a:rPr>
+              <a:t>əhifəsi var.</a:t>
+            </a:r>
+          </a:p>
+          <a:p>
+            <a:pPr>
+              <a:lnSpc>
+                <a:spcPct val="150000"/>
+              </a:lnSpc>
+              <a:buNone/>
+            </a:pPr>
+            <a:endParaRPr lang="az-Latn-AZ" altLang="en-US" sz="1100">
+              <a:latin typeface="Arial" panose="020B0604020202020204" pitchFamily="34" charset="0"/>
+            </a:endParaRPr>
+          </a:p>
+          <a:p>
+            <a:pPr>
+              <a:lnSpc>
+                <a:spcPct val="150000"/>
+              </a:lnSpc>
+              <a:buNone/>
+            </a:pPr>
+            <a:r>
+              <a:rPr lang="az-Latn-AZ" altLang="en-US" sz="1100">
+                <a:latin typeface="Arial" panose="020B0604020202020204" pitchFamily="34" charset="0"/>
+              </a:rPr>
+              <a:t>Ancaq giriş etdiyimizdə hələdə `</a:t>
+            </a:r>
+            <a:r>
+              <a:rPr lang="en-US" altLang="en-US" sz="1100" b="1">
+                <a:latin typeface="Arial" panose="020B0604020202020204" pitchFamily="34" charset="0"/>
+              </a:rPr>
+              <a:t>/dashboard</a:t>
+            </a:r>
+            <a:r>
+              <a:rPr lang="az-Latn-AZ" altLang="en-US" sz="1100">
+                <a:latin typeface="Arial" panose="020B0604020202020204" pitchFamily="34" charset="0"/>
+              </a:rPr>
+              <a:t>`</a:t>
+            </a:r>
+            <a:r>
+              <a:rPr lang="en-US" altLang="en-US" sz="1100">
+                <a:latin typeface="Arial" panose="020B0604020202020204" pitchFamily="34" charset="0"/>
+              </a:rPr>
+              <a:t> </a:t>
+            </a:r>
+            <a:r>
+              <a:rPr lang="az-Latn-AZ" altLang="en-US" sz="1100">
+                <a:latin typeface="Arial" panose="020B0604020202020204" pitchFamily="34" charset="0"/>
+              </a:rPr>
+              <a:t>səhifəsinə yönləndirilirik.</a:t>
+            </a:r>
+          </a:p>
+        </p:txBody>
+      </p:sp>
+      <p:grpSp>
+        <p:nvGrpSpPr>
+          <p:cNvPr id="8" name="Group 7">
+            <a:extLst>
+              <a:ext uri="{FF2B5EF4-FFF2-40B4-BE49-F238E27FC236}">
+                <a16:creationId xmlns:a16="http://schemas.microsoft.com/office/drawing/2014/main" id="{E4459BB8-1315-9C3E-8C41-B16AE56C69E7}"/>
+              </a:ext>
+            </a:extLst>
+          </p:cNvPr>
+          <p:cNvGrpSpPr/>
+          <p:nvPr/>
+        </p:nvGrpSpPr>
+        <p:grpSpPr>
+          <a:xfrm>
+            <a:off x="217714" y="1590582"/>
+            <a:ext cx="12192000" cy="5267418"/>
+            <a:chOff x="217714" y="1590582"/>
+            <a:chExt cx="12192000" cy="5267418"/>
+          </a:xfrm>
+        </p:grpSpPr>
+        <p:pic>
+          <p:nvPicPr>
+            <p:cNvPr id="4" name="Picture 3">
+              <a:extLst>
+                <a:ext uri="{FF2B5EF4-FFF2-40B4-BE49-F238E27FC236}">
+                  <a16:creationId xmlns:a16="http://schemas.microsoft.com/office/drawing/2014/main" id="{39804CE1-10A8-EC18-FB6D-F5567D8E028F}"/>
+                </a:ext>
+              </a:extLst>
+            </p:cNvPr>
+            <p:cNvPicPr>
+              <a:picLocks noChangeAspect="1"/>
+            </p:cNvPicPr>
+            <p:nvPr/>
+          </p:nvPicPr>
+          <p:blipFill>
+            <a:blip r:embed="rId2"/>
+            <a:stretch>
+              <a:fillRect/>
+            </a:stretch>
+          </p:blipFill>
+          <p:spPr>
+            <a:xfrm>
+              <a:off x="4943686" y="1590582"/>
+              <a:ext cx="2304626" cy="1670467"/>
+            </a:xfrm>
+            <a:prstGeom prst="rect">
+              <a:avLst/>
+            </a:prstGeom>
+            <a:ln w="38100" cap="sq">
+              <a:solidFill>
+                <a:srgbClr val="000000"/>
+              </a:solidFill>
+              <a:prstDash val="solid"/>
+              <a:miter lim="800000"/>
+            </a:ln>
+            <a:effectLst>
+              <a:outerShdw blurRad="50800" dist="38100" dir="2700000" algn="tl" rotWithShape="0">
+                <a:srgbClr val="000000">
+                  <a:alpha val="43000"/>
+                </a:srgbClr>
+              </a:outerShdw>
+            </a:effectLst>
+          </p:spPr>
+        </p:pic>
+        <p:pic>
+          <p:nvPicPr>
+            <p:cNvPr id="6" name="Picture 5">
+              <a:extLst>
+                <a:ext uri="{FF2B5EF4-FFF2-40B4-BE49-F238E27FC236}">
+                  <a16:creationId xmlns:a16="http://schemas.microsoft.com/office/drawing/2014/main" id="{A008BD7F-D7F8-B872-D5CA-DD04CA547267}"/>
+                </a:ext>
+              </a:extLst>
+            </p:cNvPr>
+            <p:cNvPicPr>
+              <a:picLocks noChangeAspect="1"/>
+            </p:cNvPicPr>
+            <p:nvPr/>
+          </p:nvPicPr>
+          <p:blipFill>
+            <a:blip r:embed="rId3"/>
+            <a:stretch>
+              <a:fillRect/>
+            </a:stretch>
+          </p:blipFill>
+          <p:spPr>
+            <a:xfrm>
+              <a:off x="217714" y="3963700"/>
+              <a:ext cx="12192000" cy="2894300"/>
+            </a:xfrm>
+            <a:prstGeom prst="rect">
+              <a:avLst/>
+            </a:prstGeom>
+          </p:spPr>
+        </p:pic>
+        <p:sp>
+          <p:nvSpPr>
+            <p:cNvPr id="7" name="Arrow: Down 6">
+              <a:extLst>
+                <a:ext uri="{FF2B5EF4-FFF2-40B4-BE49-F238E27FC236}">
+                  <a16:creationId xmlns:a16="http://schemas.microsoft.com/office/drawing/2014/main" id="{ACADDB32-2449-2EFF-74CD-A624101B652C}"/>
+                </a:ext>
+              </a:extLst>
+            </p:cNvPr>
+            <p:cNvSpPr/>
+            <p:nvPr/>
+          </p:nvSpPr>
+          <p:spPr>
+            <a:xfrm>
+              <a:off x="5867399" y="3474748"/>
+              <a:ext cx="457200" cy="427398"/>
+            </a:xfrm>
+            <a:prstGeom prst="downArrow">
+              <a:avLst/>
+            </a:prstGeom>
+          </p:spPr>
+          <p:style>
+            <a:lnRef idx="2">
+              <a:schemeClr val="dk1">
+                <a:shade val="15000"/>
+              </a:schemeClr>
+            </a:lnRef>
+            <a:fillRef idx="1">
+              <a:schemeClr val="dk1"/>
+            </a:fillRef>
+            <a:effectRef idx="0">
+              <a:schemeClr val="dk1"/>
+            </a:effectRef>
+            <a:fontRef idx="minor">
+              <a:schemeClr val="lt1"/>
+            </a:fontRef>
+          </p:style>
+          <p:txBody>
+            <a:bodyPr rtlCol="0" anchor="ctr"/>
+            <a:lstStyle/>
+            <a:p>
+              <a:pPr algn="ctr"/>
+              <a:endParaRPr lang="en-US"/>
+            </a:p>
+          </p:txBody>
+        </p:sp>
+      </p:grpSp>
     </p:spTree>
     <p:extLst>
       <p:ext uri="{BB962C8B-B14F-4D97-AF65-F5344CB8AC3E}">
@@ -3483,7 +4369,7 @@
 </p:sld>
 </file>
 
-<file path=ppt/slides/slide3.xml><?xml version="1.0" encoding="utf-8"?>
+<file path=ppt/slides/slide5.xml><?xml version="1.0" encoding="utf-8"?>
 <p:sld xmlns:a="http://schemas.openxmlformats.org/drawingml/2006/main" xmlns:r="http://schemas.openxmlformats.org/officeDocument/2006/relationships" xmlns:p="http://schemas.openxmlformats.org/presentationml/2006/main">
   <p:cSld>
     <p:spTree>
@@ -3541,7 +4427,401 @@
               <a:buNone/>
             </a:pPr>
             <a:r>
-              <a:rPr kumimoji="0" lang="en-US" altLang="en-US" sz="1300" b="0" i="0" u="none" strike="noStrike" cap="none" normalizeH="0" baseline="0">
+              <a:rPr lang="az-Latn-AZ" altLang="en-US" sz="1300">
+                <a:latin typeface="Arial" panose="020B0604020202020204" pitchFamily="34" charset="0"/>
+              </a:rPr>
+              <a:t>`</a:t>
+            </a:r>
+            <a:r>
+              <a:rPr lang="en-US" altLang="en-US" sz="1300" b="1">
+                <a:latin typeface="Arial" panose="020B0604020202020204" pitchFamily="34" charset="0"/>
+              </a:rPr>
+              <a:t>/user/dashboard</a:t>
+            </a:r>
+            <a:r>
+              <a:rPr lang="az-Latn-AZ" altLang="en-US" sz="1300">
+                <a:latin typeface="Arial" panose="020B0604020202020204" pitchFamily="34" charset="0"/>
+              </a:rPr>
+              <a:t>`</a:t>
+            </a:r>
+            <a:r>
+              <a:rPr lang="en-US" altLang="en-US" sz="1300">
+                <a:latin typeface="Arial" panose="020B0604020202020204" pitchFamily="34" charset="0"/>
+              </a:rPr>
+              <a:t> </a:t>
+            </a:r>
+            <a:r>
+              <a:rPr lang="az-Latn-AZ" altLang="en-US" sz="1300">
+                <a:latin typeface="Arial" panose="020B0604020202020204" pitchFamily="34" charset="0"/>
+              </a:rPr>
+              <a:t>səhifəsinə yönləndirilmək üçün isə, `</a:t>
+            </a:r>
+            <a:r>
+              <a:rPr lang="az-Latn-AZ" altLang="en-US" sz="1300" b="1">
+                <a:latin typeface="Arial" panose="020B0604020202020204" pitchFamily="34" charset="0"/>
+              </a:rPr>
+              <a:t>app\Providers\RouteServiceProvider.php</a:t>
+            </a:r>
+            <a:r>
+              <a:rPr lang="az-Latn-AZ" altLang="en-US" sz="1300">
+                <a:latin typeface="Arial" panose="020B0604020202020204" pitchFamily="34" charset="0"/>
+              </a:rPr>
+              <a:t>` faylında aşağıdakı kimi yazmaq lazımdır:</a:t>
+            </a:r>
+            <a:endParaRPr kumimoji="0" lang="en-US" altLang="en-US" sz="1300" b="0" i="0" u="none" strike="noStrike" cap="none" normalizeH="0" baseline="0">
+              <a:ln>
+                <a:noFill/>
+              </a:ln>
+              <a:solidFill>
+                <a:schemeClr val="tx1"/>
+              </a:solidFill>
+              <a:effectLst/>
+              <a:latin typeface="Arial" panose="020B0604020202020204" pitchFamily="34" charset="0"/>
+            </a:endParaRPr>
+          </a:p>
+        </p:txBody>
+      </p:sp>
+      <p:pic>
+        <p:nvPicPr>
+          <p:cNvPr id="4" name="Picture 3">
+            <a:extLst>
+              <a:ext uri="{FF2B5EF4-FFF2-40B4-BE49-F238E27FC236}">
+                <a16:creationId xmlns:a16="http://schemas.microsoft.com/office/drawing/2014/main" id="{6B4293EB-123A-6CEB-0E17-2D9B26A16C08}"/>
+              </a:ext>
+            </a:extLst>
+          </p:cNvPr>
+          <p:cNvPicPr>
+            <a:picLocks noChangeAspect="1"/>
+          </p:cNvPicPr>
+          <p:nvPr/>
+        </p:nvPicPr>
+        <p:blipFill>
+          <a:blip r:embed="rId2"/>
+          <a:stretch>
+            <a:fillRect/>
+          </a:stretch>
+        </p:blipFill>
+        <p:spPr>
+          <a:xfrm>
+            <a:off x="7557796" y="855018"/>
+            <a:ext cx="4634204" cy="6002982"/>
+          </a:xfrm>
+          <a:prstGeom prst="rect">
+            <a:avLst/>
+          </a:prstGeom>
+        </p:spPr>
+      </p:pic>
+    </p:spTree>
+    <p:extLst>
+      <p:ext uri="{BB962C8B-B14F-4D97-AF65-F5344CB8AC3E}">
+        <p14:creationId xmlns:p14="http://schemas.microsoft.com/office/powerpoint/2010/main" val="3095838342"/>
+      </p:ext>
+    </p:extLst>
+  </p:cSld>
+  <p:clrMapOvr>
+    <a:masterClrMapping/>
+  </p:clrMapOvr>
+</p:sld>
+</file>
+
+<file path=ppt/slides/slide6.xml><?xml version="1.0" encoding="utf-8"?>
+<p:sld xmlns:a="http://schemas.openxmlformats.org/drawingml/2006/main" xmlns:r="http://schemas.openxmlformats.org/officeDocument/2006/relationships" xmlns:p="http://schemas.openxmlformats.org/presentationml/2006/main">
+  <p:cSld>
+    <p:spTree>
+      <p:nvGrpSpPr>
+        <p:cNvPr id="1" name="">
+          <a:extLst>
+            <a:ext uri="{FF2B5EF4-FFF2-40B4-BE49-F238E27FC236}">
+              <a16:creationId xmlns:a16="http://schemas.microsoft.com/office/drawing/2014/main" id="{77E5FE22-94AC-F8A5-25E1-0F7D96FB98B5}"/>
+            </a:ext>
+          </a:extLst>
+        </p:cNvPr>
+        <p:cNvGrpSpPr/>
+        <p:nvPr/>
+      </p:nvGrpSpPr>
+      <p:grpSpPr>
+        <a:xfrm>
+          <a:off x="0" y="0"/>
+          <a:ext cx="0" cy="0"/>
+          <a:chOff x="0" y="0"/>
+          <a:chExt cx="0" cy="0"/>
+        </a:xfrm>
+      </p:grpSpPr>
+      <p:sp>
+        <p:nvSpPr>
+          <p:cNvPr id="3" name="TextBox 2">
+            <a:extLst>
+              <a:ext uri="{FF2B5EF4-FFF2-40B4-BE49-F238E27FC236}">
+                <a16:creationId xmlns:a16="http://schemas.microsoft.com/office/drawing/2014/main" id="{A80408F6-9A5F-EE0E-F146-185768CBEE61}"/>
+              </a:ext>
+            </a:extLst>
+          </p:cNvPr>
+          <p:cNvSpPr txBox="1"/>
+          <p:nvPr/>
+        </p:nvSpPr>
+        <p:spPr>
+          <a:xfrm>
+            <a:off x="217714" y="255046"/>
+            <a:ext cx="11756571" cy="355354"/>
+          </a:xfrm>
+          <a:prstGeom prst="rect">
+            <a:avLst/>
+          </a:prstGeom>
+          <a:noFill/>
+        </p:spPr>
+        <p:txBody>
+          <a:bodyPr wrap="square">
+            <a:spAutoFit/>
+          </a:bodyPr>
+          <a:lstStyle/>
+          <a:p>
+            <a:pPr>
+              <a:lnSpc>
+                <a:spcPct val="150000"/>
+              </a:lnSpc>
+              <a:buNone/>
+            </a:pPr>
+            <a:r>
+              <a:rPr lang="en-US" altLang="en-US" sz="1300">
+                <a:latin typeface="Arial" panose="020B0604020202020204" pitchFamily="34" charset="0"/>
+              </a:rPr>
+              <a:t>Sistem</a:t>
+            </a:r>
+            <a:r>
+              <a:rPr lang="az-Latn-AZ" altLang="en-US" sz="1300">
+                <a:latin typeface="Arial" panose="020B0604020202020204" pitchFamily="34" charset="0"/>
+              </a:rPr>
+              <a:t>ə sadə </a:t>
+            </a:r>
+            <a:r>
+              <a:rPr lang="az-Latn-AZ" altLang="en-US" sz="1300" b="1">
+                <a:latin typeface="Arial" panose="020B0604020202020204" pitchFamily="34" charset="0"/>
+              </a:rPr>
+              <a:t>user</a:t>
+            </a:r>
+            <a:r>
+              <a:rPr lang="az-Latn-AZ" altLang="en-US" sz="1300">
+                <a:latin typeface="Arial" panose="020B0604020202020204" pitchFamily="34" charset="0"/>
+              </a:rPr>
+              <a:t> kimi daxil olduqdan sonra, URL bölməsində `</a:t>
+            </a:r>
+            <a:r>
+              <a:rPr lang="az-Latn-AZ" altLang="en-US" sz="1300" b="1">
+                <a:latin typeface="Arial" panose="020B0604020202020204" pitchFamily="34" charset="0"/>
+              </a:rPr>
+              <a:t>http://vendor-e-commerce.test/admin/dashboard</a:t>
+            </a:r>
+            <a:r>
+              <a:rPr lang="az-Latn-AZ" altLang="en-US" sz="1300">
+                <a:latin typeface="Arial" panose="020B0604020202020204" pitchFamily="34" charset="0"/>
+              </a:rPr>
+              <a:t>` yazsaq onda aşağıdakı kimi xəta alarıq:</a:t>
+            </a:r>
+            <a:endParaRPr kumimoji="0" lang="en-US" altLang="en-US" sz="1300" b="0" i="0" u="none" strike="noStrike" cap="none" normalizeH="0" baseline="0">
+              <a:ln>
+                <a:noFill/>
+              </a:ln>
+              <a:solidFill>
+                <a:schemeClr val="tx1"/>
+              </a:solidFill>
+              <a:effectLst/>
+              <a:latin typeface="Arial" panose="020B0604020202020204" pitchFamily="34" charset="0"/>
+            </a:endParaRPr>
+          </a:p>
+        </p:txBody>
+      </p:sp>
+      <p:pic>
+        <p:nvPicPr>
+          <p:cNvPr id="4" name="Picture 3">
+            <a:extLst>
+              <a:ext uri="{FF2B5EF4-FFF2-40B4-BE49-F238E27FC236}">
+                <a16:creationId xmlns:a16="http://schemas.microsoft.com/office/drawing/2014/main" id="{334670CE-8C98-D1CA-38A5-13A920DB00F8}"/>
+              </a:ext>
+            </a:extLst>
+          </p:cNvPr>
+          <p:cNvPicPr>
+            <a:picLocks noChangeAspect="1"/>
+          </p:cNvPicPr>
+          <p:nvPr/>
+        </p:nvPicPr>
+        <p:blipFill>
+          <a:blip r:embed="rId2"/>
+          <a:stretch>
+            <a:fillRect/>
+          </a:stretch>
+        </p:blipFill>
+        <p:spPr>
+          <a:xfrm>
+            <a:off x="4943686" y="1590582"/>
+            <a:ext cx="2304626" cy="1670467"/>
+          </a:xfrm>
+          <a:prstGeom prst="rect">
+            <a:avLst/>
+          </a:prstGeom>
+          <a:ln w="38100" cap="sq">
+            <a:solidFill>
+              <a:srgbClr val="000000"/>
+            </a:solidFill>
+            <a:prstDash val="solid"/>
+            <a:miter lim="800000"/>
+          </a:ln>
+          <a:effectLst>
+            <a:outerShdw blurRad="50800" dist="38100" dir="2700000" algn="tl" rotWithShape="0">
+              <a:srgbClr val="000000">
+                <a:alpha val="43000"/>
+              </a:srgbClr>
+            </a:outerShdw>
+          </a:effectLst>
+        </p:spPr>
+      </p:pic>
+      <p:sp>
+        <p:nvSpPr>
+          <p:cNvPr id="6" name="Arrow: Down 5">
+            <a:extLst>
+              <a:ext uri="{FF2B5EF4-FFF2-40B4-BE49-F238E27FC236}">
+                <a16:creationId xmlns:a16="http://schemas.microsoft.com/office/drawing/2014/main" id="{5B23D757-4687-9556-510D-CED7947EC912}"/>
+              </a:ext>
+            </a:extLst>
+          </p:cNvPr>
+          <p:cNvSpPr/>
+          <p:nvPr/>
+        </p:nvSpPr>
+        <p:spPr>
+          <a:xfrm>
+            <a:off x="5867399" y="3474748"/>
+            <a:ext cx="457200" cy="427398"/>
+          </a:xfrm>
+          <a:prstGeom prst="downArrow">
+            <a:avLst/>
+          </a:prstGeom>
+        </p:spPr>
+        <p:style>
+          <a:lnRef idx="2">
+            <a:schemeClr val="dk1">
+              <a:shade val="15000"/>
+            </a:schemeClr>
+          </a:lnRef>
+          <a:fillRef idx="1">
+            <a:schemeClr val="dk1"/>
+          </a:fillRef>
+          <a:effectRef idx="0">
+            <a:schemeClr val="dk1"/>
+          </a:effectRef>
+          <a:fontRef idx="minor">
+            <a:schemeClr val="lt1"/>
+          </a:fontRef>
+        </p:style>
+        <p:txBody>
+          <a:bodyPr rtlCol="0" anchor="ctr"/>
+          <a:lstStyle/>
+          <a:p>
+            <a:pPr algn="ctr"/>
+            <a:endParaRPr lang="en-US"/>
+          </a:p>
+        </p:txBody>
+      </p:sp>
+      <p:pic>
+        <p:nvPicPr>
+          <p:cNvPr id="8" name="Picture 7">
+            <a:extLst>
+              <a:ext uri="{FF2B5EF4-FFF2-40B4-BE49-F238E27FC236}">
+                <a16:creationId xmlns:a16="http://schemas.microsoft.com/office/drawing/2014/main" id="{B5D999B4-217A-EF86-A0C7-26CA5B15856F}"/>
+              </a:ext>
+            </a:extLst>
+          </p:cNvPr>
+          <p:cNvPicPr>
+            <a:picLocks noChangeAspect="1"/>
+          </p:cNvPicPr>
+          <p:nvPr/>
+        </p:nvPicPr>
+        <p:blipFill>
+          <a:blip r:embed="rId3"/>
+          <a:stretch>
+            <a:fillRect/>
+          </a:stretch>
+        </p:blipFill>
+        <p:spPr>
+          <a:xfrm>
+            <a:off x="3292150" y="4082752"/>
+            <a:ext cx="5833189" cy="2775248"/>
+          </a:xfrm>
+          <a:prstGeom prst="rect">
+            <a:avLst/>
+          </a:prstGeom>
+        </p:spPr>
+      </p:pic>
+    </p:spTree>
+    <p:extLst>
+      <p:ext uri="{BB962C8B-B14F-4D97-AF65-F5344CB8AC3E}">
+        <p14:creationId xmlns:p14="http://schemas.microsoft.com/office/powerpoint/2010/main" val="2995343931"/>
+      </p:ext>
+    </p:extLst>
+  </p:cSld>
+  <p:clrMapOvr>
+    <a:masterClrMapping/>
+  </p:clrMapOvr>
+</p:sld>
+</file>
+
+<file path=ppt/slides/slide7.xml><?xml version="1.0" encoding="utf-8"?>
+<p:sld xmlns:a="http://schemas.openxmlformats.org/drawingml/2006/main" xmlns:r="http://schemas.openxmlformats.org/officeDocument/2006/relationships" xmlns:p="http://schemas.openxmlformats.org/presentationml/2006/main">
+  <p:cSld>
+    <p:spTree>
+      <p:nvGrpSpPr>
+        <p:cNvPr id="1" name="">
+          <a:extLst>
+            <a:ext uri="{FF2B5EF4-FFF2-40B4-BE49-F238E27FC236}">
+              <a16:creationId xmlns:a16="http://schemas.microsoft.com/office/drawing/2014/main" id="{552336A1-12D0-F83A-E757-BB47E6A50AD3}"/>
+            </a:ext>
+          </a:extLst>
+        </p:cNvPr>
+        <p:cNvGrpSpPr/>
+        <p:nvPr/>
+      </p:nvGrpSpPr>
+      <p:grpSpPr>
+        <a:xfrm>
+          <a:off x="0" y="0"/>
+          <a:ext cx="0" cy="0"/>
+          <a:chOff x="0" y="0"/>
+          <a:chExt cx="0" cy="0"/>
+        </a:xfrm>
+      </p:grpSpPr>
+      <p:sp>
+        <p:nvSpPr>
+          <p:cNvPr id="3" name="TextBox 2">
+            <a:extLst>
+              <a:ext uri="{FF2B5EF4-FFF2-40B4-BE49-F238E27FC236}">
+                <a16:creationId xmlns:a16="http://schemas.microsoft.com/office/drawing/2014/main" id="{55642312-8B5A-2D2E-CAC5-9D6744971525}"/>
+              </a:ext>
+            </a:extLst>
+          </p:cNvPr>
+          <p:cNvSpPr txBox="1"/>
+          <p:nvPr/>
+        </p:nvSpPr>
+        <p:spPr>
+          <a:xfrm>
+            <a:off x="217714" y="255046"/>
+            <a:ext cx="11756571" cy="355354"/>
+          </a:xfrm>
+          <a:prstGeom prst="rect">
+            <a:avLst/>
+          </a:prstGeom>
+          <a:noFill/>
+        </p:spPr>
+        <p:txBody>
+          <a:bodyPr wrap="square">
+            <a:spAutoFit/>
+          </a:bodyPr>
+          <a:lstStyle/>
+          <a:p>
+            <a:pPr>
+              <a:lnSpc>
+                <a:spcPct val="150000"/>
+              </a:lnSpc>
+              <a:buNone/>
+            </a:pPr>
+            <a:r>
+              <a:rPr kumimoji="0" lang="az-Latn-AZ" altLang="en-US" sz="1300" b="0" i="0" u="none" strike="noStrike" cap="none" normalizeH="0" baseline="0">
                 <a:ln>
                   <a:noFill/>
                 </a:ln>
@@ -3551,15 +4831,497 @@
                 <a:effectLst/>
                 <a:latin typeface="Arial" panose="020B0604020202020204" pitchFamily="34" charset="0"/>
               </a:rPr>
-              <a:t>.</a:t>
-            </a:r>
-          </a:p>
-        </p:txBody>
-      </p:sp>
+              <a:t>Bu xətanı aradan qaldırmaq üçün isə be</a:t>
+            </a:r>
+            <a:r>
+              <a:rPr lang="az-Latn-AZ" altLang="en-US" sz="1300">
+                <a:latin typeface="Arial" panose="020B0604020202020204" pitchFamily="34" charset="0"/>
+              </a:rPr>
+              <a:t>lə yazmaq lazımdır:</a:t>
+            </a:r>
+            <a:endParaRPr kumimoji="0" lang="en-US" altLang="en-US" sz="1300" b="0" i="0" u="none" strike="noStrike" cap="none" normalizeH="0" baseline="0">
+              <a:ln>
+                <a:noFill/>
+              </a:ln>
+              <a:solidFill>
+                <a:schemeClr val="tx1"/>
+              </a:solidFill>
+              <a:effectLst/>
+              <a:latin typeface="Arial" panose="020B0604020202020204" pitchFamily="34" charset="0"/>
+            </a:endParaRPr>
+          </a:p>
+        </p:txBody>
+      </p:sp>
+      <p:pic>
+        <p:nvPicPr>
+          <p:cNvPr id="4" name="Picture 3">
+            <a:extLst>
+              <a:ext uri="{FF2B5EF4-FFF2-40B4-BE49-F238E27FC236}">
+                <a16:creationId xmlns:a16="http://schemas.microsoft.com/office/drawing/2014/main" id="{C1ADB643-8CF4-5080-50FC-C56A53B61A06}"/>
+              </a:ext>
+            </a:extLst>
+          </p:cNvPr>
+          <p:cNvPicPr>
+            <a:picLocks noChangeAspect="1"/>
+          </p:cNvPicPr>
+          <p:nvPr/>
+        </p:nvPicPr>
+        <p:blipFill>
+          <a:blip r:embed="rId2"/>
+          <a:stretch>
+            <a:fillRect/>
+          </a:stretch>
+        </p:blipFill>
+        <p:spPr>
+          <a:xfrm>
+            <a:off x="217714" y="923575"/>
+            <a:ext cx="7382905" cy="5010849"/>
+          </a:xfrm>
+          <a:prstGeom prst="rect">
+            <a:avLst/>
+          </a:prstGeom>
+        </p:spPr>
+      </p:pic>
     </p:spTree>
     <p:extLst>
       <p:ext uri="{BB962C8B-B14F-4D97-AF65-F5344CB8AC3E}">
-        <p14:creationId xmlns:p14="http://schemas.microsoft.com/office/powerpoint/2010/main" val="3095838342"/>
+        <p14:creationId xmlns:p14="http://schemas.microsoft.com/office/powerpoint/2010/main" val="67455195"/>
+      </p:ext>
+    </p:extLst>
+  </p:cSld>
+  <p:clrMapOvr>
+    <a:masterClrMapping/>
+  </p:clrMapOvr>
+</p:sld>
+</file>
+
+<file path=ppt/slides/slide8.xml><?xml version="1.0" encoding="utf-8"?>
+<p:sld xmlns:a="http://schemas.openxmlformats.org/drawingml/2006/main" xmlns:r="http://schemas.openxmlformats.org/officeDocument/2006/relationships" xmlns:p="http://schemas.openxmlformats.org/presentationml/2006/main">
+  <p:cSld>
+    <p:spTree>
+      <p:nvGrpSpPr>
+        <p:cNvPr id="1" name="">
+          <a:extLst>
+            <a:ext uri="{FF2B5EF4-FFF2-40B4-BE49-F238E27FC236}">
+              <a16:creationId xmlns:a16="http://schemas.microsoft.com/office/drawing/2014/main" id="{66886616-97C7-1A26-F5BC-2F23048705A6}"/>
+            </a:ext>
+          </a:extLst>
+        </p:cNvPr>
+        <p:cNvGrpSpPr/>
+        <p:nvPr/>
+      </p:nvGrpSpPr>
+      <p:grpSpPr>
+        <a:xfrm>
+          <a:off x="0" y="0"/>
+          <a:ext cx="0" cy="0"/>
+          <a:chOff x="0" y="0"/>
+          <a:chExt cx="0" cy="0"/>
+        </a:xfrm>
+      </p:grpSpPr>
+      <p:sp>
+        <p:nvSpPr>
+          <p:cNvPr id="3" name="TextBox 2">
+            <a:extLst>
+              <a:ext uri="{FF2B5EF4-FFF2-40B4-BE49-F238E27FC236}">
+                <a16:creationId xmlns:a16="http://schemas.microsoft.com/office/drawing/2014/main" id="{4E063DBF-2AAB-31C6-3C55-D8D2E81BF2E0}"/>
+              </a:ext>
+            </a:extLst>
+          </p:cNvPr>
+          <p:cNvSpPr txBox="1"/>
+          <p:nvPr/>
+        </p:nvSpPr>
+        <p:spPr>
+          <a:xfrm>
+            <a:off x="217714" y="255046"/>
+            <a:ext cx="11756571" cy="2455929"/>
+          </a:xfrm>
+          <a:prstGeom prst="rect">
+            <a:avLst/>
+          </a:prstGeom>
+          <a:noFill/>
+        </p:spPr>
+        <p:txBody>
+          <a:bodyPr wrap="square">
+            <a:spAutoFit/>
+          </a:bodyPr>
+          <a:lstStyle/>
+          <a:p>
+            <a:pPr>
+              <a:lnSpc>
+                <a:spcPct val="150000"/>
+              </a:lnSpc>
+              <a:buNone/>
+            </a:pPr>
+            <a:r>
+              <a:rPr lang="az-Latn-AZ" altLang="en-US" sz="1300">
+                <a:latin typeface="Arial" panose="020B0604020202020204" pitchFamily="34" charset="0"/>
+              </a:rPr>
+              <a:t>Növbəti dəvə URL -də belə yazdıqda: </a:t>
+            </a:r>
+          </a:p>
+          <a:p>
+            <a:pPr>
+              <a:lnSpc>
+                <a:spcPct val="150000"/>
+              </a:lnSpc>
+              <a:buNone/>
+            </a:pPr>
+            <a:endParaRPr kumimoji="0" lang="az-Latn-AZ" altLang="en-US" sz="1300" b="0" i="0" u="none" strike="noStrike" cap="none" normalizeH="0" baseline="0">
+              <a:ln>
+                <a:noFill/>
+              </a:ln>
+              <a:solidFill>
+                <a:schemeClr val="tx1"/>
+              </a:solidFill>
+              <a:effectLst/>
+              <a:latin typeface="Arial" panose="020B0604020202020204" pitchFamily="34" charset="0"/>
+            </a:endParaRPr>
+          </a:p>
+          <a:p>
+            <a:pPr>
+              <a:lnSpc>
+                <a:spcPct val="150000"/>
+              </a:lnSpc>
+              <a:buNone/>
+            </a:pPr>
+            <a:endParaRPr lang="az-Latn-AZ" altLang="en-US" sz="1300">
+              <a:latin typeface="Arial" panose="020B0604020202020204" pitchFamily="34" charset="0"/>
+            </a:endParaRPr>
+          </a:p>
+          <a:p>
+            <a:pPr>
+              <a:lnSpc>
+                <a:spcPct val="150000"/>
+              </a:lnSpc>
+              <a:buNone/>
+            </a:pPr>
+            <a:endParaRPr kumimoji="0" lang="az-Latn-AZ" altLang="en-US" sz="1300" b="0" i="0" u="none" strike="noStrike" cap="none" normalizeH="0" baseline="0">
+              <a:ln>
+                <a:noFill/>
+              </a:ln>
+              <a:solidFill>
+                <a:schemeClr val="tx1"/>
+              </a:solidFill>
+              <a:effectLst/>
+              <a:latin typeface="Arial" panose="020B0604020202020204" pitchFamily="34" charset="0"/>
+            </a:endParaRPr>
+          </a:p>
+          <a:p>
+            <a:pPr>
+              <a:lnSpc>
+                <a:spcPct val="150000"/>
+              </a:lnSpc>
+              <a:buNone/>
+            </a:pPr>
+            <a:endParaRPr lang="az-Latn-AZ" altLang="en-US" sz="1300">
+              <a:latin typeface="Arial" panose="020B0604020202020204" pitchFamily="34" charset="0"/>
+            </a:endParaRPr>
+          </a:p>
+          <a:p>
+            <a:pPr>
+              <a:lnSpc>
+                <a:spcPct val="150000"/>
+              </a:lnSpc>
+              <a:buNone/>
+            </a:pPr>
+            <a:endParaRPr kumimoji="0" lang="az-Latn-AZ" altLang="en-US" sz="1300" b="0" i="0" u="none" strike="noStrike" cap="none" normalizeH="0" baseline="0">
+              <a:ln>
+                <a:noFill/>
+              </a:ln>
+              <a:solidFill>
+                <a:schemeClr val="tx1"/>
+              </a:solidFill>
+              <a:effectLst/>
+              <a:latin typeface="Arial" panose="020B0604020202020204" pitchFamily="34" charset="0"/>
+            </a:endParaRPr>
+          </a:p>
+          <a:p>
+            <a:pPr>
+              <a:lnSpc>
+                <a:spcPct val="150000"/>
+              </a:lnSpc>
+              <a:buNone/>
+            </a:pPr>
+            <a:endParaRPr lang="az-Latn-AZ" altLang="en-US" sz="1300">
+              <a:latin typeface="Arial" panose="020B0604020202020204" pitchFamily="34" charset="0"/>
+            </a:endParaRPr>
+          </a:p>
+          <a:p>
+            <a:pPr>
+              <a:lnSpc>
+                <a:spcPct val="150000"/>
+              </a:lnSpc>
+              <a:buNone/>
+            </a:pPr>
+            <a:r>
+              <a:rPr lang="az-Latn-AZ" altLang="en-US" sz="1300">
+                <a:latin typeface="Arial" panose="020B0604020202020204" pitchFamily="34" charset="0"/>
+              </a:rPr>
+              <a:t>Yenə `</a:t>
+            </a:r>
+            <a:r>
+              <a:rPr lang="az-Latn-AZ" altLang="en-US" sz="1300" b="1">
+                <a:latin typeface="Arial" panose="020B0604020202020204" pitchFamily="34" charset="0"/>
+              </a:rPr>
+              <a:t>http://vendor-e-commerce.test/dashboard</a:t>
+            </a:r>
+            <a:r>
+              <a:rPr lang="az-Latn-AZ" altLang="en-US" sz="1300">
+                <a:latin typeface="Arial" panose="020B0604020202020204" pitchFamily="34" charset="0"/>
+              </a:rPr>
+              <a:t>` bu cür </a:t>
+            </a:r>
+            <a:r>
+              <a:rPr lang="az-Latn-AZ" altLang="en-US" sz="1300" b="1">
+                <a:latin typeface="Arial" panose="020B0604020202020204" pitchFamily="34" charset="0"/>
+              </a:rPr>
+              <a:t>URL</a:t>
+            </a:r>
+            <a:r>
+              <a:rPr lang="az-Latn-AZ" altLang="en-US" sz="1300">
+                <a:latin typeface="Arial" panose="020B0604020202020204" pitchFamily="34" charset="0"/>
+              </a:rPr>
+              <a:t> -yə yönləndiriləcəyik. Ancaq belə bir </a:t>
+            </a:r>
+            <a:r>
+              <a:rPr lang="az-Latn-AZ" altLang="en-US" sz="1300" b="1">
+                <a:latin typeface="Arial" panose="020B0604020202020204" pitchFamily="34" charset="0"/>
+              </a:rPr>
+              <a:t>URL</a:t>
+            </a:r>
+            <a:r>
+              <a:rPr lang="az-Latn-AZ" altLang="en-US" sz="1300">
+                <a:latin typeface="Arial" panose="020B0604020202020204" pitchFamily="34" charset="0"/>
+              </a:rPr>
+              <a:t> yoxdur.</a:t>
+            </a:r>
+            <a:endParaRPr kumimoji="0" lang="en-US" altLang="en-US" sz="1300" b="0" i="0" u="none" strike="noStrike" cap="none" normalizeH="0" baseline="0">
+              <a:ln>
+                <a:noFill/>
+              </a:ln>
+              <a:solidFill>
+                <a:schemeClr val="tx1"/>
+              </a:solidFill>
+              <a:effectLst/>
+              <a:latin typeface="Arial" panose="020B0604020202020204" pitchFamily="34" charset="0"/>
+            </a:endParaRPr>
+          </a:p>
+        </p:txBody>
+      </p:sp>
+      <p:pic>
+        <p:nvPicPr>
+          <p:cNvPr id="4" name="Picture 3">
+            <a:extLst>
+              <a:ext uri="{FF2B5EF4-FFF2-40B4-BE49-F238E27FC236}">
+                <a16:creationId xmlns:a16="http://schemas.microsoft.com/office/drawing/2014/main" id="{70AD5916-B4D7-C0E0-0657-CFC483696A26}"/>
+              </a:ext>
+            </a:extLst>
+          </p:cNvPr>
+          <p:cNvPicPr>
+            <a:picLocks noChangeAspect="1"/>
+          </p:cNvPicPr>
+          <p:nvPr/>
+        </p:nvPicPr>
+        <p:blipFill>
+          <a:blip r:embed="rId2"/>
+          <a:stretch>
+            <a:fillRect/>
+          </a:stretch>
+        </p:blipFill>
+        <p:spPr>
+          <a:xfrm>
+            <a:off x="3038047" y="1051979"/>
+            <a:ext cx="6115904" cy="685896"/>
+          </a:xfrm>
+          <a:prstGeom prst="rect">
+            <a:avLst/>
+          </a:prstGeom>
+        </p:spPr>
+      </p:pic>
+      <p:pic>
+        <p:nvPicPr>
+          <p:cNvPr id="6" name="Picture 5">
+            <a:extLst>
+              <a:ext uri="{FF2B5EF4-FFF2-40B4-BE49-F238E27FC236}">
+                <a16:creationId xmlns:a16="http://schemas.microsoft.com/office/drawing/2014/main" id="{BE25E4B4-289A-0668-2807-E50000A518AF}"/>
+              </a:ext>
+            </a:extLst>
+          </p:cNvPr>
+          <p:cNvPicPr>
+            <a:picLocks noChangeAspect="1"/>
+          </p:cNvPicPr>
+          <p:nvPr/>
+        </p:nvPicPr>
+        <p:blipFill>
+          <a:blip r:embed="rId3"/>
+          <a:stretch>
+            <a:fillRect/>
+          </a:stretch>
+        </p:blipFill>
+        <p:spPr>
+          <a:xfrm>
+            <a:off x="0" y="4113851"/>
+            <a:ext cx="12192000" cy="2744149"/>
+          </a:xfrm>
+          <a:prstGeom prst="rect">
+            <a:avLst/>
+          </a:prstGeom>
+        </p:spPr>
+      </p:pic>
+    </p:spTree>
+    <p:extLst>
+      <p:ext uri="{BB962C8B-B14F-4D97-AF65-F5344CB8AC3E}">
+        <p14:creationId xmlns:p14="http://schemas.microsoft.com/office/powerpoint/2010/main" val="872913219"/>
+      </p:ext>
+    </p:extLst>
+  </p:cSld>
+  <p:clrMapOvr>
+    <a:masterClrMapping/>
+  </p:clrMapOvr>
+</p:sld>
+</file>
+
+<file path=ppt/slides/slide9.xml><?xml version="1.0" encoding="utf-8"?>
+<p:sld xmlns:a="http://schemas.openxmlformats.org/drawingml/2006/main" xmlns:r="http://schemas.openxmlformats.org/officeDocument/2006/relationships" xmlns:p="http://schemas.openxmlformats.org/presentationml/2006/main">
+  <p:cSld>
+    <p:spTree>
+      <p:nvGrpSpPr>
+        <p:cNvPr id="1" name="">
+          <a:extLst>
+            <a:ext uri="{FF2B5EF4-FFF2-40B4-BE49-F238E27FC236}">
+              <a16:creationId xmlns:a16="http://schemas.microsoft.com/office/drawing/2014/main" id="{A22557B4-63A2-ABA1-9A9E-BCCABFB604E6}"/>
+            </a:ext>
+          </a:extLst>
+        </p:cNvPr>
+        <p:cNvGrpSpPr/>
+        <p:nvPr/>
+      </p:nvGrpSpPr>
+      <p:grpSpPr>
+        <a:xfrm>
+          <a:off x="0" y="0"/>
+          <a:ext cx="0" cy="0"/>
+          <a:chOff x="0" y="0"/>
+          <a:chExt cx="0" cy="0"/>
+        </a:xfrm>
+      </p:grpSpPr>
+      <p:sp>
+        <p:nvSpPr>
+          <p:cNvPr id="3" name="TextBox 2">
+            <a:extLst>
+              <a:ext uri="{FF2B5EF4-FFF2-40B4-BE49-F238E27FC236}">
+                <a16:creationId xmlns:a16="http://schemas.microsoft.com/office/drawing/2014/main" id="{28CCCA5F-6A67-EE16-5C80-6AB50FF560FF}"/>
+              </a:ext>
+            </a:extLst>
+          </p:cNvPr>
+          <p:cNvSpPr txBox="1"/>
+          <p:nvPr/>
+        </p:nvSpPr>
+        <p:spPr>
+          <a:xfrm>
+            <a:off x="217714" y="255046"/>
+            <a:ext cx="11756571" cy="355354"/>
+          </a:xfrm>
+          <a:prstGeom prst="rect">
+            <a:avLst/>
+          </a:prstGeom>
+          <a:noFill/>
+        </p:spPr>
+        <p:txBody>
+          <a:bodyPr wrap="square">
+            <a:spAutoFit/>
+          </a:bodyPr>
+          <a:lstStyle/>
+          <a:p>
+            <a:pPr>
+              <a:lnSpc>
+                <a:spcPct val="150000"/>
+              </a:lnSpc>
+              <a:buNone/>
+            </a:pPr>
+            <a:r>
+              <a:rPr lang="az-Latn-AZ" altLang="en-US" sz="1300">
+                <a:latin typeface="Arial" panose="020B0604020202020204" pitchFamily="34" charset="0"/>
+              </a:rPr>
+              <a:t>B</a:t>
+            </a:r>
+            <a:r>
+              <a:rPr kumimoji="0" lang="az-Latn-AZ" altLang="en-US" sz="1300" b="0" i="0" u="none" strike="noStrike" cap="none" normalizeH="0" baseline="0">
+                <a:ln>
+                  <a:noFill/>
+                </a:ln>
+                <a:solidFill>
+                  <a:schemeClr val="tx1"/>
+                </a:solidFill>
+                <a:effectLst/>
+                <a:latin typeface="Arial" panose="020B0604020202020204" pitchFamily="34" charset="0"/>
+              </a:rPr>
+              <a:t>u xətanıda aradan qaldırmaq üçün </a:t>
+            </a:r>
+            <a:r>
+              <a:rPr lang="az-Latn-AZ" altLang="en-US" sz="1300">
+                <a:latin typeface="Arial" panose="020B0604020202020204" pitchFamily="34" charset="0"/>
+              </a:rPr>
+              <a:t>`</a:t>
+            </a:r>
+            <a:r>
+              <a:rPr lang="az-Latn-AZ" altLang="en-US" sz="1300" b="1">
+                <a:latin typeface="Arial" panose="020B0604020202020204" pitchFamily="34" charset="0"/>
+              </a:rPr>
+              <a:t>app\Http\Middleware\RedirectIfAuthenticatedAdmin.php</a:t>
+            </a:r>
+            <a:r>
+              <a:rPr lang="az-Latn-AZ" altLang="en-US" sz="1300">
+                <a:latin typeface="Arial" panose="020B0604020202020204" pitchFamily="34" charset="0"/>
+              </a:rPr>
+              <a:t>` faylında, aşağıdakı kimi dəyişiklik etməliyik: </a:t>
+            </a:r>
+            <a:endParaRPr kumimoji="0" lang="en-US" altLang="en-US" sz="1300" b="0" i="0" u="none" strike="noStrike" cap="none" normalizeH="0" baseline="0">
+              <a:ln>
+                <a:noFill/>
+              </a:ln>
+              <a:solidFill>
+                <a:schemeClr val="tx1"/>
+              </a:solidFill>
+              <a:effectLst/>
+              <a:latin typeface="Arial" panose="020B0604020202020204" pitchFamily="34" charset="0"/>
+            </a:endParaRPr>
+          </a:p>
+        </p:txBody>
+      </p:sp>
+      <p:pic>
+        <p:nvPicPr>
+          <p:cNvPr id="4" name="Picture 3">
+            <a:extLst>
+              <a:ext uri="{FF2B5EF4-FFF2-40B4-BE49-F238E27FC236}">
+                <a16:creationId xmlns:a16="http://schemas.microsoft.com/office/drawing/2014/main" id="{B7F00707-62BA-E88C-87F2-AB659DC1CE87}"/>
+              </a:ext>
+            </a:extLst>
+          </p:cNvPr>
+          <p:cNvPicPr>
+            <a:picLocks noChangeAspect="1"/>
+          </p:cNvPicPr>
+          <p:nvPr/>
+        </p:nvPicPr>
+        <p:blipFill>
+          <a:blip r:embed="rId2"/>
+          <a:stretch>
+            <a:fillRect/>
+          </a:stretch>
+        </p:blipFill>
+        <p:spPr>
+          <a:xfrm>
+            <a:off x="3166652" y="1151729"/>
+            <a:ext cx="5858693" cy="5706271"/>
+          </a:xfrm>
+          <a:prstGeom prst="rect">
+            <a:avLst/>
+          </a:prstGeom>
+        </p:spPr>
+      </p:pic>
+    </p:spTree>
+    <p:extLst>
+      <p:ext uri="{BB962C8B-B14F-4D97-AF65-F5344CB8AC3E}">
+        <p14:creationId xmlns:p14="http://schemas.microsoft.com/office/powerpoint/2010/main" val="2227315219"/>
       </p:ext>
     </p:extLst>
   </p:cSld>

</xml_diff>